<commit_message>
update slides and intern tasks
</commit_message>
<xml_diff>
--- a/docs/base_slides.pptx
+++ b/docs/base_slides.pptx
@@ -5,7 +5,7 @@
     <p:sldMasterId id="2147483648" r:id="rId1"/>
   </p:sldMasterIdLst>
   <p:notesMasterIdLst>
-    <p:notesMasterId r:id="rId10"/>
+    <p:notesMasterId r:id="rId12"/>
   </p:notesMasterIdLst>
   <p:sldIdLst>
     <p:sldId id="1574" r:id="rId2"/>
@@ -15,7 +15,9 @@
     <p:sldId id="1577" r:id="rId6"/>
     <p:sldId id="1582" r:id="rId7"/>
     <p:sldId id="1583" r:id="rId8"/>
-    <p:sldId id="1628" r:id="rId9"/>
+    <p:sldId id="1591" r:id="rId9"/>
+    <p:sldId id="1628" r:id="rId10"/>
+    <p:sldId id="1613" r:id="rId11"/>
   </p:sldIdLst>
   <p:sldSz cx="12192000" cy="6858000"/>
   <p:notesSz cx="6858000" cy="9144000"/>
@@ -126,7 +128,9 @@
             <p14:sldId id="1577"/>
             <p14:sldId id="1582"/>
             <p14:sldId id="1583"/>
+            <p14:sldId id="1591"/>
             <p14:sldId id="1628"/>
+            <p14:sldId id="1613"/>
           </p14:sldIdLst>
         </p14:section>
       </p14:sectionLst>
@@ -953,7 +957,7 @@
           <a:pPr rtl="0"/>
           <a:r>
             <a:rPr lang="en-GB" dirty="0"/>
-            <a:t>successful information operation </a:t>
+            <a:t>Successful information operation </a:t>
           </a:r>
           <a:r>
             <a:rPr lang="en-GB" b="0" dirty="0"/>
@@ -1508,7 +1512,7 @@
           </a:pPr>
           <a:r>
             <a:rPr lang="en-GB" sz="1800" kern="1200" dirty="0"/>
-            <a:t>successful information operation </a:t>
+            <a:t>Successful information operation </a:t>
           </a:r>
           <a:r>
             <a:rPr lang="en-GB" sz="1800" b="0" kern="1200" dirty="0"/>
@@ -3356,7 +3360,7 @@
           <a:p>
             <a:fld id="{2915196C-CDBC-4DEE-A220-849C85FC22AC}" type="datetimeFigureOut">
               <a:rPr lang="he-IL" smtClean="0"/>
-              <a:t>ו'/אדר/תשפ"ו</a:t>
+              <a:t>י"א/אדר/תשפ"ו</a:t>
             </a:fld>
             <a:endParaRPr lang="he-IL"/>
           </a:p>
@@ -3889,6 +3893,236 @@
 </p:notes>
 </file>
 
+<file path=ppt/notesSlides/notesSlide2.xml><?xml version="1.0" encoding="utf-8"?>
+<p:notes xmlns:a="http://schemas.openxmlformats.org/drawingml/2006/main" xmlns:r="http://schemas.openxmlformats.org/officeDocument/2006/relationships" xmlns:p="http://schemas.openxmlformats.org/presentationml/2006/main">
+  <p:cSld>
+    <p:spTree>
+      <p:nvGrpSpPr>
+        <p:cNvPr id="1" name="">
+          <a:extLst>
+            <a:ext uri="{FF2B5EF4-FFF2-40B4-BE49-F238E27FC236}">
+              <a16:creationId xmlns:a16="http://schemas.microsoft.com/office/drawing/2014/main" id="{5F2D1760-78DB-D18D-FBB8-239E0A7E745F}"/>
+            </a:ext>
+          </a:extLst>
+        </p:cNvPr>
+        <p:cNvGrpSpPr/>
+        <p:nvPr/>
+      </p:nvGrpSpPr>
+      <p:grpSpPr>
+        <a:xfrm>
+          <a:off x="0" y="0"/>
+          <a:ext cx="0" cy="0"/>
+          <a:chOff x="0" y="0"/>
+          <a:chExt cx="0" cy="0"/>
+        </a:xfrm>
+      </p:grpSpPr>
+      <p:sp>
+        <p:nvSpPr>
+          <p:cNvPr id="2" name="Slide Image Placeholder 1">
+            <a:extLst>
+              <a:ext uri="{FF2B5EF4-FFF2-40B4-BE49-F238E27FC236}">
+                <a16:creationId xmlns:a16="http://schemas.microsoft.com/office/drawing/2014/main" id="{502EC71B-5AA6-886B-0231-A74B41DE5028}"/>
+              </a:ext>
+            </a:extLst>
+          </p:cNvPr>
+          <p:cNvSpPr>
+            <a:spLocks noGrp="1" noRot="1" noChangeAspect="1"/>
+          </p:cNvSpPr>
+          <p:nvPr>
+            <p:ph type="sldImg"/>
+          </p:nvPr>
+        </p:nvSpPr>
+        <p:spPr/>
+        <p:txBody>
+          <a:bodyPr/>
+          <a:lstStyle/>
+          <a:p>
+            <a:endParaRPr lang="en-IL"/>
+          </a:p>
+        </p:txBody>
+      </p:sp>
+      <p:sp>
+        <p:nvSpPr>
+          <p:cNvPr id="3" name="Notes Placeholder 2">
+            <a:extLst>
+              <a:ext uri="{FF2B5EF4-FFF2-40B4-BE49-F238E27FC236}">
+                <a16:creationId xmlns:a16="http://schemas.microsoft.com/office/drawing/2014/main" id="{0FD997CC-4715-39C7-93DD-C967C30807B4}"/>
+              </a:ext>
+            </a:extLst>
+          </p:cNvPr>
+          <p:cNvSpPr>
+            <a:spLocks noGrp="1"/>
+          </p:cNvSpPr>
+          <p:nvPr>
+            <p:ph type="body" idx="1"/>
+          </p:nvPr>
+        </p:nvSpPr>
+        <p:spPr/>
+        <p:txBody>
+          <a:bodyPr/>
+          <a:lstStyle/>
+          <a:p>
+            <a:endParaRPr lang="en-IL" dirty="0"/>
+          </a:p>
+        </p:txBody>
+      </p:sp>
+      <p:sp>
+        <p:nvSpPr>
+          <p:cNvPr id="4" name="Slide Number Placeholder 3">
+            <a:extLst>
+              <a:ext uri="{FF2B5EF4-FFF2-40B4-BE49-F238E27FC236}">
+                <a16:creationId xmlns:a16="http://schemas.microsoft.com/office/drawing/2014/main" id="{D1C57815-7BE0-C4B1-B3D0-083C2D02FC95}"/>
+              </a:ext>
+            </a:extLst>
+          </p:cNvPr>
+          <p:cNvSpPr>
+            <a:spLocks noGrp="1"/>
+          </p:cNvSpPr>
+          <p:nvPr>
+            <p:ph type="sldNum" sz="quarter" idx="5"/>
+          </p:nvPr>
+        </p:nvSpPr>
+        <p:spPr/>
+        <p:txBody>
+          <a:bodyPr/>
+          <a:lstStyle/>
+          <a:p>
+            <a:fld id="{7F6CD5E7-A5BE-4430-AD67-E129D63AAC5C}" type="slidenum">
+              <a:rPr lang="he-IL" smtClean="0"/>
+              <a:t>8</a:t>
+            </a:fld>
+            <a:endParaRPr lang="he-IL"/>
+          </a:p>
+        </p:txBody>
+      </p:sp>
+    </p:spTree>
+    <p:extLst>
+      <p:ext uri="{BB962C8B-B14F-4D97-AF65-F5344CB8AC3E}">
+        <p14:creationId xmlns:p14="http://schemas.microsoft.com/office/powerpoint/2010/main" val="1668725800"/>
+      </p:ext>
+    </p:extLst>
+  </p:cSld>
+  <p:clrMapOvr>
+    <a:masterClrMapping/>
+  </p:clrMapOvr>
+</p:notes>
+</file>
+
+<file path=ppt/notesSlides/notesSlide3.xml><?xml version="1.0" encoding="utf-8"?>
+<p:notes xmlns:a="http://schemas.openxmlformats.org/drawingml/2006/main" xmlns:r="http://schemas.openxmlformats.org/officeDocument/2006/relationships" xmlns:p="http://schemas.openxmlformats.org/presentationml/2006/main">
+  <p:cSld>
+    <p:spTree>
+      <p:nvGrpSpPr>
+        <p:cNvPr id="1" name="">
+          <a:extLst>
+            <a:ext uri="{FF2B5EF4-FFF2-40B4-BE49-F238E27FC236}">
+              <a16:creationId xmlns:a16="http://schemas.microsoft.com/office/drawing/2014/main" id="{F72473ED-A99E-1255-DF0A-F46C0A3F8A2E}"/>
+            </a:ext>
+          </a:extLst>
+        </p:cNvPr>
+        <p:cNvGrpSpPr/>
+        <p:nvPr/>
+      </p:nvGrpSpPr>
+      <p:grpSpPr>
+        <a:xfrm>
+          <a:off x="0" y="0"/>
+          <a:ext cx="0" cy="0"/>
+          <a:chOff x="0" y="0"/>
+          <a:chExt cx="0" cy="0"/>
+        </a:xfrm>
+      </p:grpSpPr>
+      <p:sp>
+        <p:nvSpPr>
+          <p:cNvPr id="2" name="Slide Image Placeholder 1">
+            <a:extLst>
+              <a:ext uri="{FF2B5EF4-FFF2-40B4-BE49-F238E27FC236}">
+                <a16:creationId xmlns:a16="http://schemas.microsoft.com/office/drawing/2014/main" id="{B138042E-74BF-F12B-EB05-B5A12A791608}"/>
+              </a:ext>
+            </a:extLst>
+          </p:cNvPr>
+          <p:cNvSpPr>
+            <a:spLocks noGrp="1" noRot="1" noChangeAspect="1"/>
+          </p:cNvSpPr>
+          <p:nvPr>
+            <p:ph type="sldImg"/>
+          </p:nvPr>
+        </p:nvSpPr>
+        <p:spPr/>
+        <p:txBody>
+          <a:bodyPr/>
+          <a:lstStyle/>
+          <a:p>
+            <a:endParaRPr lang="en-IL"/>
+          </a:p>
+        </p:txBody>
+      </p:sp>
+      <p:sp>
+        <p:nvSpPr>
+          <p:cNvPr id="3" name="Notes Placeholder 2">
+            <a:extLst>
+              <a:ext uri="{FF2B5EF4-FFF2-40B4-BE49-F238E27FC236}">
+                <a16:creationId xmlns:a16="http://schemas.microsoft.com/office/drawing/2014/main" id="{9FF9362C-8306-7A0F-CDF5-AFC8289AE917}"/>
+              </a:ext>
+            </a:extLst>
+          </p:cNvPr>
+          <p:cNvSpPr>
+            <a:spLocks noGrp="1"/>
+          </p:cNvSpPr>
+          <p:nvPr>
+            <p:ph type="body" idx="1"/>
+          </p:nvPr>
+        </p:nvSpPr>
+        <p:spPr/>
+        <p:txBody>
+          <a:bodyPr/>
+          <a:lstStyle/>
+          <a:p>
+            <a:endParaRPr lang="en-IL" dirty="0"/>
+          </a:p>
+        </p:txBody>
+      </p:sp>
+      <p:sp>
+        <p:nvSpPr>
+          <p:cNvPr id="4" name="Slide Number Placeholder 3">
+            <a:extLst>
+              <a:ext uri="{FF2B5EF4-FFF2-40B4-BE49-F238E27FC236}">
+                <a16:creationId xmlns:a16="http://schemas.microsoft.com/office/drawing/2014/main" id="{7C4EDC18-E9C8-4ECA-7039-35E23F9D9DA3}"/>
+              </a:ext>
+            </a:extLst>
+          </p:cNvPr>
+          <p:cNvSpPr>
+            <a:spLocks noGrp="1"/>
+          </p:cNvSpPr>
+          <p:nvPr>
+            <p:ph type="sldNum" sz="quarter" idx="5"/>
+          </p:nvPr>
+        </p:nvSpPr>
+        <p:spPr/>
+        <p:txBody>
+          <a:bodyPr/>
+          <a:lstStyle/>
+          <a:p>
+            <a:fld id="{7F6CD5E7-A5BE-4430-AD67-E129D63AAC5C}" type="slidenum">
+              <a:rPr lang="he-IL" smtClean="0"/>
+              <a:t>10</a:t>
+            </a:fld>
+            <a:endParaRPr lang="he-IL"/>
+          </a:p>
+        </p:txBody>
+      </p:sp>
+    </p:spTree>
+    <p:extLst>
+      <p:ext uri="{BB962C8B-B14F-4D97-AF65-F5344CB8AC3E}">
+        <p14:creationId xmlns:p14="http://schemas.microsoft.com/office/powerpoint/2010/main" val="2057236096"/>
+      </p:ext>
+    </p:extLst>
+  </p:cSld>
+  <p:clrMapOvr>
+    <a:masterClrMapping/>
+  </p:clrMapOvr>
+</p:notes>
+</file>
+
 <file path=ppt/slideLayouts/slideLayout1.xml><?xml version="1.0" encoding="utf-8"?>
 <p:sldLayout xmlns:a="http://schemas.openxmlformats.org/drawingml/2006/main" xmlns:r="http://schemas.openxmlformats.org/officeDocument/2006/relationships" xmlns:p="http://schemas.openxmlformats.org/presentationml/2006/main" type="title" preserve="1">
   <p:cSld name="Title Slide">
@@ -4075,7 +4309,7 @@
           <a:p>
             <a:fld id="{FC6B3A86-AB79-4388-8CA5-9FC4B834779B}" type="datetime8">
               <a:rPr lang="he-IL" smtClean="0"/>
-              <a:t>23 פברואר 26</a:t>
+              <a:t>28 פברואר 26</a:t>
             </a:fld>
             <a:endParaRPr lang="he-IL"/>
           </a:p>
@@ -4298,7 +4532,7 @@
           <a:p>
             <a:fld id="{18F56BC8-8E7D-4896-9980-77BC87FB8E3E}" type="datetime8">
               <a:rPr lang="he-IL" smtClean="0"/>
-              <a:t>23 פברואר 26</a:t>
+              <a:t>28 פברואר 26</a:t>
             </a:fld>
             <a:endParaRPr lang="he-IL"/>
           </a:p>
@@ -4531,7 +4765,7 @@
           <a:p>
             <a:fld id="{0FE327C8-CB36-417E-834B-544633ADCE63}" type="datetime8">
               <a:rPr lang="he-IL" smtClean="0"/>
-              <a:t>23 פברואר 26</a:t>
+              <a:t>28 פברואר 26</a:t>
             </a:fld>
             <a:endParaRPr lang="he-IL"/>
           </a:p>
@@ -4649,7 +4883,7 @@
           <a:p>
             <a:fld id="{8E065D1C-C98B-44F5-AB2A-FEE3E85D0A94}" type="datetime8">
               <a:rPr lang="he-IL" smtClean="0"/>
-              <a:t>23 פברואר 26</a:t>
+              <a:t>28 פברואר 26</a:t>
             </a:fld>
             <a:endParaRPr lang="he-IL"/>
           </a:p>
@@ -4712,10 +4946,10 @@
       </p:sp>
       <p:pic>
         <p:nvPicPr>
-          <p:cNvPr id="6" name="Picture 5" descr="A document with text on it&#10;&#10;AI-generated content may be incorrect.">
-            <a:extLst>
-              <a:ext uri="{FF2B5EF4-FFF2-40B4-BE49-F238E27FC236}">
-                <a16:creationId xmlns:a16="http://schemas.microsoft.com/office/drawing/2014/main" id="{C90561FF-B0EA-0CEF-2458-5237DB16069C}"/>
+          <p:cNvPr id="7" name="Picture 6" descr="A document with text on it&#10;&#10;AI-generated content may be incorrect.">
+            <a:extLst>
+              <a:ext uri="{FF2B5EF4-FFF2-40B4-BE49-F238E27FC236}">
+                <a16:creationId xmlns:a16="http://schemas.microsoft.com/office/drawing/2014/main" id="{221434F7-1295-8CB3-5E53-891A52C3D78D}"/>
               </a:ext>
             </a:extLst>
           </p:cNvPr>
@@ -4732,15 +4966,15 @@
               </a:ext>
             </a:extLst>
           </a:blip>
-          <a:srcRect l="11423" t="8775" r="7050" b="78302"/>
+          <a:srcRect l="11606" t="8664" r="8034" b="78094"/>
           <a:stretch>
             <a:fillRect/>
           </a:stretch>
         </p:blipFill>
         <p:spPr>
           <a:xfrm>
-            <a:off x="1004330" y="2463070"/>
-            <a:ext cx="10889267" cy="2233697"/>
+            <a:off x="1038256" y="2478278"/>
+            <a:ext cx="10821413" cy="2294289"/>
           </a:xfrm>
           <a:prstGeom prst="rect">
             <a:avLst/>
@@ -4960,7 +5194,7 @@
           <a:p>
             <a:fld id="{7634CBFB-2532-48BA-BAE2-ADD925390740}" type="datetime8">
               <a:rPr lang="he-IL" smtClean="0"/>
-              <a:t>23 פברואר 26</a:t>
+              <a:t>28 פברואר 26</a:t>
             </a:fld>
             <a:endParaRPr lang="he-IL"/>
           </a:p>
@@ -5243,7 +5477,7 @@
           <a:p>
             <a:fld id="{8EAC1FDD-37C4-4A6B-BF31-779943CE32CF}" type="datetime8">
               <a:rPr lang="he-IL" smtClean="0"/>
-              <a:t>23 פברואר 26</a:t>
+              <a:t>28 פברואר 26</a:t>
             </a:fld>
             <a:endParaRPr lang="he-IL"/>
           </a:p>
@@ -5556,7 +5790,7 @@
           <a:p>
             <a:fld id="{C73C226C-A76A-4927-8F1D-1BD4AC033ABB}" type="datetime8">
               <a:rPr lang="he-IL" smtClean="0"/>
-              <a:t>23 פברואר 26</a:t>
+              <a:t>28 פברואר 26</a:t>
             </a:fld>
             <a:endParaRPr lang="he-IL"/>
           </a:p>
@@ -6059,7 +6293,7 @@
           <a:p>
             <a:fld id="{430DF2BF-D428-43E9-B36B-6DD16CF93579}" type="datetime8">
               <a:rPr lang="he-IL" smtClean="0"/>
-              <a:t>23 פברואר 26</a:t>
+              <a:t>28 פברואר 26</a:t>
             </a:fld>
             <a:endParaRPr lang="he-IL"/>
           </a:p>
@@ -6206,7 +6440,7 @@
           <a:p>
             <a:fld id="{390A9136-4922-4C74-B05C-12CD0951E601}" type="datetime8">
               <a:rPr lang="he-IL" smtClean="0"/>
-              <a:t>23 פברואר 26</a:t>
+              <a:t>28 פברואר 26</a:t>
             </a:fld>
             <a:endParaRPr lang="he-IL"/>
           </a:p>
@@ -6324,7 +6558,7 @@
           <a:p>
             <a:fld id="{C29F3CA8-2E63-412C-AA06-0D760EBE5965}" type="datetime8">
               <a:rPr lang="he-IL" smtClean="0"/>
-              <a:t>23 פברואר 26</a:t>
+              <a:t>28 פברואר 26</a:t>
             </a:fld>
             <a:endParaRPr lang="he-IL"/>
           </a:p>
@@ -6646,7 +6880,7 @@
           <a:p>
             <a:fld id="{7AC7B867-AA4A-4FF3-AD8B-0AD0F18EE595}" type="datetime8">
               <a:rPr lang="he-IL" smtClean="0"/>
-              <a:t>23 פברואר 26</a:t>
+              <a:t>28 פברואר 26</a:t>
             </a:fld>
             <a:endParaRPr lang="he-IL"/>
           </a:p>
@@ -6944,7 +7178,7 @@
           <a:p>
             <a:fld id="{F5E9EBD3-88E8-46DB-BD3B-F935B7013014}" type="datetime8">
               <a:rPr lang="he-IL" smtClean="0"/>
-              <a:t>23 פברואר 26</a:t>
+              <a:t>28 פברואר 26</a:t>
             </a:fld>
             <a:endParaRPr lang="he-IL"/>
           </a:p>
@@ -7228,7 +7462,7 @@
           <a:p>
             <a:fld id="{8E065D1C-C98B-44F5-AB2A-FEE3E85D0A94}" type="datetime8">
               <a:rPr lang="he-IL" smtClean="0"/>
-              <a:t>23 פברואר 26</a:t>
+              <a:t>28 פברואר 26</a:t>
             </a:fld>
             <a:endParaRPr lang="he-IL"/>
           </a:p>
@@ -8037,7 +8271,7 @@
                   <a:prstClr val="white"/>
                 </a:solidFill>
               </a:rPr>
-              <a:t>31.12.3000</a:t>
+              <a:t>30.12.3000</a:t>
             </a:r>
           </a:p>
           <a:p>
@@ -8344,6 +8578,715 @@
 </p:sld>
 </file>
 
+<file path=ppt/slides/slide10.xml><?xml version="1.0" encoding="utf-8"?>
+<p:sld xmlns:a="http://schemas.openxmlformats.org/drawingml/2006/main" xmlns:r="http://schemas.openxmlformats.org/officeDocument/2006/relationships" xmlns:p="http://schemas.openxmlformats.org/presentationml/2006/main">
+  <p:cSld>
+    <p:spTree>
+      <p:nvGrpSpPr>
+        <p:cNvPr id="1" name="">
+          <a:extLst>
+            <a:ext uri="{FF2B5EF4-FFF2-40B4-BE49-F238E27FC236}">
+              <a16:creationId xmlns:a16="http://schemas.microsoft.com/office/drawing/2014/main" id="{4F0BEF17-A85B-69A7-4947-96097D1A5F5B}"/>
+            </a:ext>
+          </a:extLst>
+        </p:cNvPr>
+        <p:cNvGrpSpPr/>
+        <p:nvPr/>
+      </p:nvGrpSpPr>
+      <p:grpSpPr>
+        <a:xfrm>
+          <a:off x="0" y="0"/>
+          <a:ext cx="0" cy="0"/>
+          <a:chOff x="0" y="0"/>
+          <a:chExt cx="0" cy="0"/>
+        </a:xfrm>
+      </p:grpSpPr>
+      <p:sp>
+        <p:nvSpPr>
+          <p:cNvPr id="2" name="Title 1">
+            <a:extLst>
+              <a:ext uri="{FF2B5EF4-FFF2-40B4-BE49-F238E27FC236}">
+                <a16:creationId xmlns:a16="http://schemas.microsoft.com/office/drawing/2014/main" id="{F80E2D88-5AB1-052E-FB13-E091040FA2F1}"/>
+              </a:ext>
+            </a:extLst>
+          </p:cNvPr>
+          <p:cNvSpPr>
+            <a:spLocks noGrp="1"/>
+          </p:cNvSpPr>
+          <p:nvPr>
+            <p:ph type="title"/>
+          </p:nvPr>
+        </p:nvSpPr>
+        <p:spPr>
+          <a:xfrm>
+            <a:off x="3072268" y="401637"/>
+            <a:ext cx="8949044" cy="1325563"/>
+          </a:xfrm>
+        </p:spPr>
+        <p:txBody>
+          <a:bodyPr>
+            <a:normAutofit/>
+          </a:bodyPr>
+          <a:lstStyle/>
+          <a:p>
+            <a:r>
+              <a:rPr lang="en-GB" dirty="0"/>
+              <a:t>Backbone Graph &amp; IO Indicators</a:t>
+            </a:r>
+            <a:endParaRPr lang="en-IL" dirty="0"/>
+          </a:p>
+        </p:txBody>
+      </p:sp>
+      <p:sp>
+        <p:nvSpPr>
+          <p:cNvPr id="4" name="Slide Number Placeholder 3">
+            <a:extLst>
+              <a:ext uri="{FF2B5EF4-FFF2-40B4-BE49-F238E27FC236}">
+                <a16:creationId xmlns:a16="http://schemas.microsoft.com/office/drawing/2014/main" id="{9A45DFBC-E283-482F-07BA-A333B9108357}"/>
+              </a:ext>
+            </a:extLst>
+          </p:cNvPr>
+          <p:cNvSpPr>
+            <a:spLocks noGrp="1"/>
+          </p:cNvSpPr>
+          <p:nvPr>
+            <p:ph type="sldNum" sz="quarter" idx="12"/>
+          </p:nvPr>
+        </p:nvSpPr>
+        <p:spPr/>
+        <p:txBody>
+          <a:bodyPr/>
+          <a:lstStyle/>
+          <a:p>
+            <a:fld id="{E6AB8EDD-9EF2-4633-A1C2-4D908C1019B4}" type="slidenum">
+              <a:rPr lang="he-IL" smtClean="0"/>
+              <a:t>10</a:t>
+            </a:fld>
+            <a:endParaRPr lang="he-IL"/>
+          </a:p>
+        </p:txBody>
+      </p:sp>
+      <p:pic>
+        <p:nvPicPr>
+          <p:cNvPr id="8" name="Content Placeholder 7" descr="A network of dots and lines&#10;&#10;AI-generated content may be incorrect.">
+            <a:extLst>
+              <a:ext uri="{FF2B5EF4-FFF2-40B4-BE49-F238E27FC236}">
+                <a16:creationId xmlns:a16="http://schemas.microsoft.com/office/drawing/2014/main" id="{66A4053E-AB18-5F2F-D1F0-F2B2E5298473}"/>
+              </a:ext>
+            </a:extLst>
+          </p:cNvPr>
+          <p:cNvPicPr>
+            <a:picLocks noGrp="1" noChangeAspect="1"/>
+          </p:cNvPicPr>
+          <p:nvPr>
+            <p:ph idx="1"/>
+          </p:nvPr>
+        </p:nvPicPr>
+        <p:blipFill>
+          <a:blip r:embed="rId3">
+            <a:extLst>
+              <a:ext uri="{28A0092B-C50C-407E-A947-70E740481C1C}">
+                <a14:useLocalDpi xmlns:a14="http://schemas.microsoft.com/office/drawing/2010/main" val="0"/>
+              </a:ext>
+            </a:extLst>
+          </a:blip>
+          <a:srcRect l="3852" t="3063" r="4355"/>
+          <a:stretch>
+            <a:fillRect/>
+          </a:stretch>
+        </p:blipFill>
+        <p:spPr>
+          <a:xfrm>
+            <a:off x="1616927" y="1630362"/>
+            <a:ext cx="6362773" cy="5176361"/>
+          </a:xfrm>
+        </p:spPr>
+      </p:pic>
+      <p:sp>
+        <p:nvSpPr>
+          <p:cNvPr id="5" name="Flowchart: Connector 4">
+            <a:extLst>
+              <a:ext uri="{FF2B5EF4-FFF2-40B4-BE49-F238E27FC236}">
+                <a16:creationId xmlns:a16="http://schemas.microsoft.com/office/drawing/2014/main" id="{94C0EF37-C21E-64B9-190B-12A5FFAC380E}"/>
+              </a:ext>
+            </a:extLst>
+          </p:cNvPr>
+          <p:cNvSpPr/>
+          <p:nvPr/>
+        </p:nvSpPr>
+        <p:spPr>
+          <a:xfrm>
+            <a:off x="6840109" y="4305300"/>
+            <a:ext cx="558911" cy="559646"/>
+          </a:xfrm>
+          <a:prstGeom prst="flowChartConnector">
+            <a:avLst/>
+          </a:prstGeom>
+          <a:noFill/>
+          <a:ln w="57150">
+            <a:solidFill>
+              <a:schemeClr val="accent1"/>
+            </a:solidFill>
+          </a:ln>
+        </p:spPr>
+        <p:style>
+          <a:lnRef idx="2">
+            <a:schemeClr val="accent1">
+              <a:shade val="15000"/>
+            </a:schemeClr>
+          </a:lnRef>
+          <a:fillRef idx="1">
+            <a:schemeClr val="accent1"/>
+          </a:fillRef>
+          <a:effectRef idx="0">
+            <a:schemeClr val="accent1"/>
+          </a:effectRef>
+          <a:fontRef idx="minor">
+            <a:schemeClr val="lt1"/>
+          </a:fontRef>
+        </p:style>
+        <p:txBody>
+          <a:bodyPr rtlCol="0" anchor="ctr"/>
+          <a:lstStyle/>
+          <a:p>
+            <a:pPr algn="ctr"/>
+            <a:endParaRPr lang="en-IL"/>
+          </a:p>
+        </p:txBody>
+      </p:sp>
+      <p:sp>
+        <p:nvSpPr>
+          <p:cNvPr id="6" name="Flowchart: Connector 5">
+            <a:extLst>
+              <a:ext uri="{FF2B5EF4-FFF2-40B4-BE49-F238E27FC236}">
+                <a16:creationId xmlns:a16="http://schemas.microsoft.com/office/drawing/2014/main" id="{D78D894D-6702-3125-2BFF-3DB2ECBA4904}"/>
+              </a:ext>
+            </a:extLst>
+          </p:cNvPr>
+          <p:cNvSpPr/>
+          <p:nvPr/>
+        </p:nvSpPr>
+        <p:spPr>
+          <a:xfrm>
+            <a:off x="8256994" y="2008500"/>
+            <a:ext cx="360000" cy="360000"/>
+          </a:xfrm>
+          <a:prstGeom prst="flowChartConnector">
+            <a:avLst/>
+          </a:prstGeom>
+          <a:noFill/>
+          <a:ln w="57150">
+            <a:solidFill>
+              <a:schemeClr val="accent1"/>
+            </a:solidFill>
+          </a:ln>
+        </p:spPr>
+        <p:style>
+          <a:lnRef idx="2">
+            <a:schemeClr val="accent1">
+              <a:shade val="15000"/>
+            </a:schemeClr>
+          </a:lnRef>
+          <a:fillRef idx="1">
+            <a:schemeClr val="accent1"/>
+          </a:fillRef>
+          <a:effectRef idx="0">
+            <a:schemeClr val="accent1"/>
+          </a:effectRef>
+          <a:fontRef idx="minor">
+            <a:schemeClr val="lt1"/>
+          </a:fontRef>
+        </p:style>
+        <p:txBody>
+          <a:bodyPr rtlCol="0" anchor="ctr"/>
+          <a:lstStyle/>
+          <a:p>
+            <a:pPr algn="ctr"/>
+            <a:endParaRPr lang="en-IL"/>
+          </a:p>
+        </p:txBody>
+      </p:sp>
+      <p:sp>
+        <p:nvSpPr>
+          <p:cNvPr id="7" name="TextBox 6">
+            <a:extLst>
+              <a:ext uri="{FF2B5EF4-FFF2-40B4-BE49-F238E27FC236}">
+                <a16:creationId xmlns:a16="http://schemas.microsoft.com/office/drawing/2014/main" id="{0199B6F5-B9F8-08F7-1704-81E9386024CC}"/>
+              </a:ext>
+            </a:extLst>
+          </p:cNvPr>
+          <p:cNvSpPr txBox="1"/>
+          <p:nvPr/>
+        </p:nvSpPr>
+        <p:spPr>
+          <a:xfrm>
+            <a:off x="8824162" y="1983610"/>
+            <a:ext cx="2630126" cy="369332"/>
+          </a:xfrm>
+          <a:prstGeom prst="rect">
+            <a:avLst/>
+          </a:prstGeom>
+          <a:noFill/>
+        </p:spPr>
+        <p:txBody>
+          <a:bodyPr wrap="square" rtlCol="0">
+            <a:spAutoFit/>
+          </a:bodyPr>
+          <a:lstStyle/>
+          <a:p>
+            <a:r>
+              <a:rPr lang="en-US" dirty="0"/>
+              <a:t>high </a:t>
+            </a:r>
+            <a:r>
+              <a:rPr lang="en-GB" dirty="0"/>
+              <a:t>degree centrality </a:t>
+            </a:r>
+            <a:endParaRPr lang="en-IL" dirty="0"/>
+          </a:p>
+        </p:txBody>
+      </p:sp>
+      <p:sp>
+        <p:nvSpPr>
+          <p:cNvPr id="9" name="Flowchart: Connector 8">
+            <a:extLst>
+              <a:ext uri="{FF2B5EF4-FFF2-40B4-BE49-F238E27FC236}">
+                <a16:creationId xmlns:a16="http://schemas.microsoft.com/office/drawing/2014/main" id="{755C2BB5-5CCD-8048-0623-B56A7107E499}"/>
+              </a:ext>
+            </a:extLst>
+          </p:cNvPr>
+          <p:cNvSpPr/>
+          <p:nvPr/>
+        </p:nvSpPr>
+        <p:spPr>
+          <a:xfrm>
+            <a:off x="1738768" y="3086616"/>
+            <a:ext cx="1057772" cy="891024"/>
+          </a:xfrm>
+          <a:prstGeom prst="flowChartConnector">
+            <a:avLst/>
+          </a:prstGeom>
+          <a:noFill/>
+          <a:ln w="57150">
+            <a:solidFill>
+              <a:srgbClr val="F59120"/>
+            </a:solidFill>
+          </a:ln>
+        </p:spPr>
+        <p:style>
+          <a:lnRef idx="2">
+            <a:schemeClr val="accent1">
+              <a:shade val="15000"/>
+            </a:schemeClr>
+          </a:lnRef>
+          <a:fillRef idx="1">
+            <a:schemeClr val="accent1"/>
+          </a:fillRef>
+          <a:effectRef idx="0">
+            <a:schemeClr val="accent1"/>
+          </a:effectRef>
+          <a:fontRef idx="minor">
+            <a:schemeClr val="lt1"/>
+          </a:fontRef>
+        </p:style>
+        <p:txBody>
+          <a:bodyPr rtlCol="0" anchor="ctr"/>
+          <a:lstStyle/>
+          <a:p>
+            <a:pPr algn="ctr"/>
+            <a:endParaRPr lang="en-IL"/>
+          </a:p>
+        </p:txBody>
+      </p:sp>
+      <p:sp>
+        <p:nvSpPr>
+          <p:cNvPr id="10" name="Flowchart: Connector 9">
+            <a:extLst>
+              <a:ext uri="{FF2B5EF4-FFF2-40B4-BE49-F238E27FC236}">
+                <a16:creationId xmlns:a16="http://schemas.microsoft.com/office/drawing/2014/main" id="{28978A85-2029-EA91-65C8-D4836607FD42}"/>
+              </a:ext>
+            </a:extLst>
+          </p:cNvPr>
+          <p:cNvSpPr/>
+          <p:nvPr/>
+        </p:nvSpPr>
+        <p:spPr>
+          <a:xfrm>
+            <a:off x="8256994" y="3116584"/>
+            <a:ext cx="360000" cy="360000"/>
+          </a:xfrm>
+          <a:prstGeom prst="flowChartConnector">
+            <a:avLst/>
+          </a:prstGeom>
+          <a:noFill/>
+          <a:ln w="57150">
+            <a:solidFill>
+              <a:srgbClr val="F59120"/>
+            </a:solidFill>
+          </a:ln>
+        </p:spPr>
+        <p:style>
+          <a:lnRef idx="2">
+            <a:schemeClr val="accent1">
+              <a:shade val="15000"/>
+            </a:schemeClr>
+          </a:lnRef>
+          <a:fillRef idx="1">
+            <a:schemeClr val="accent1"/>
+          </a:fillRef>
+          <a:effectRef idx="0">
+            <a:schemeClr val="accent1"/>
+          </a:effectRef>
+          <a:fontRef idx="minor">
+            <a:schemeClr val="lt1"/>
+          </a:fontRef>
+        </p:style>
+        <p:txBody>
+          <a:bodyPr rtlCol="0" anchor="ctr"/>
+          <a:lstStyle/>
+          <a:p>
+            <a:pPr algn="ctr"/>
+            <a:endParaRPr lang="en-IL"/>
+          </a:p>
+        </p:txBody>
+      </p:sp>
+      <p:sp>
+        <p:nvSpPr>
+          <p:cNvPr id="11" name="TextBox 10">
+            <a:extLst>
+              <a:ext uri="{FF2B5EF4-FFF2-40B4-BE49-F238E27FC236}">
+                <a16:creationId xmlns:a16="http://schemas.microsoft.com/office/drawing/2014/main" id="{F3425336-454F-FE31-1422-436892C703EC}"/>
+              </a:ext>
+            </a:extLst>
+          </p:cNvPr>
+          <p:cNvSpPr txBox="1"/>
+          <p:nvPr/>
+        </p:nvSpPr>
+        <p:spPr>
+          <a:xfrm>
+            <a:off x="8824162" y="3095422"/>
+            <a:ext cx="2630126" cy="369332"/>
+          </a:xfrm>
+          <a:prstGeom prst="rect">
+            <a:avLst/>
+          </a:prstGeom>
+          <a:noFill/>
+        </p:spPr>
+        <p:txBody>
+          <a:bodyPr wrap="square" rtlCol="0">
+            <a:spAutoFit/>
+          </a:bodyPr>
+          <a:lstStyle/>
+          <a:p>
+            <a:r>
+              <a:rPr lang="en-US" dirty="0"/>
+              <a:t>high </a:t>
+            </a:r>
+            <a:r>
+              <a:rPr lang="en-GB" dirty="0"/>
+              <a:t>k-core</a:t>
+            </a:r>
+            <a:endParaRPr lang="en-IL" dirty="0"/>
+          </a:p>
+        </p:txBody>
+      </p:sp>
+      <p:sp>
+        <p:nvSpPr>
+          <p:cNvPr id="12" name="Flowchart: Connector 11">
+            <a:extLst>
+              <a:ext uri="{FF2B5EF4-FFF2-40B4-BE49-F238E27FC236}">
+                <a16:creationId xmlns:a16="http://schemas.microsoft.com/office/drawing/2014/main" id="{871B8A36-FB76-083A-5FA0-EA7EA872E11A}"/>
+              </a:ext>
+            </a:extLst>
+          </p:cNvPr>
+          <p:cNvSpPr/>
+          <p:nvPr/>
+        </p:nvSpPr>
+        <p:spPr>
+          <a:xfrm>
+            <a:off x="8256994" y="3670626"/>
+            <a:ext cx="360000" cy="360000"/>
+          </a:xfrm>
+          <a:prstGeom prst="flowChartConnector">
+            <a:avLst/>
+          </a:prstGeom>
+          <a:noFill/>
+          <a:ln w="57150">
+            <a:solidFill>
+              <a:srgbClr val="F58377"/>
+            </a:solidFill>
+          </a:ln>
+        </p:spPr>
+        <p:style>
+          <a:lnRef idx="2">
+            <a:schemeClr val="accent1">
+              <a:shade val="15000"/>
+            </a:schemeClr>
+          </a:lnRef>
+          <a:fillRef idx="1">
+            <a:schemeClr val="accent1"/>
+          </a:fillRef>
+          <a:effectRef idx="0">
+            <a:schemeClr val="accent1"/>
+          </a:effectRef>
+          <a:fontRef idx="minor">
+            <a:schemeClr val="lt1"/>
+          </a:fontRef>
+        </p:style>
+        <p:txBody>
+          <a:bodyPr rtlCol="0" anchor="ctr"/>
+          <a:lstStyle/>
+          <a:p>
+            <a:pPr algn="ctr"/>
+            <a:endParaRPr lang="en-IL"/>
+          </a:p>
+        </p:txBody>
+      </p:sp>
+      <p:sp>
+        <p:nvSpPr>
+          <p:cNvPr id="13" name="Flowchart: Connector 12">
+            <a:extLst>
+              <a:ext uri="{FF2B5EF4-FFF2-40B4-BE49-F238E27FC236}">
+                <a16:creationId xmlns:a16="http://schemas.microsoft.com/office/drawing/2014/main" id="{BCE1F5E2-96CB-66E7-B575-B51DA37B4E37}"/>
+              </a:ext>
+            </a:extLst>
+          </p:cNvPr>
+          <p:cNvSpPr/>
+          <p:nvPr/>
+        </p:nvSpPr>
+        <p:spPr>
+          <a:xfrm>
+            <a:off x="3481782" y="3449324"/>
+            <a:ext cx="2251102" cy="1539240"/>
+          </a:xfrm>
+          <a:prstGeom prst="flowChartConnector">
+            <a:avLst/>
+          </a:prstGeom>
+          <a:noFill/>
+          <a:ln w="57150">
+            <a:solidFill>
+              <a:srgbClr val="F58377"/>
+            </a:solidFill>
+          </a:ln>
+        </p:spPr>
+        <p:style>
+          <a:lnRef idx="2">
+            <a:schemeClr val="accent1">
+              <a:shade val="15000"/>
+            </a:schemeClr>
+          </a:lnRef>
+          <a:fillRef idx="1">
+            <a:schemeClr val="accent1"/>
+          </a:fillRef>
+          <a:effectRef idx="0">
+            <a:schemeClr val="accent1"/>
+          </a:effectRef>
+          <a:fontRef idx="minor">
+            <a:schemeClr val="lt1"/>
+          </a:fontRef>
+        </p:style>
+        <p:txBody>
+          <a:bodyPr rtlCol="0" anchor="ctr"/>
+          <a:lstStyle/>
+          <a:p>
+            <a:pPr algn="ctr"/>
+            <a:endParaRPr lang="en-IL"/>
+          </a:p>
+        </p:txBody>
+      </p:sp>
+      <p:sp>
+        <p:nvSpPr>
+          <p:cNvPr id="14" name="TextBox 13">
+            <a:extLst>
+              <a:ext uri="{FF2B5EF4-FFF2-40B4-BE49-F238E27FC236}">
+                <a16:creationId xmlns:a16="http://schemas.microsoft.com/office/drawing/2014/main" id="{78B54FF2-3B58-D836-F1A2-897465C04679}"/>
+              </a:ext>
+            </a:extLst>
+          </p:cNvPr>
+          <p:cNvSpPr txBox="1"/>
+          <p:nvPr/>
+        </p:nvSpPr>
+        <p:spPr>
+          <a:xfrm>
+            <a:off x="8824162" y="3698672"/>
+            <a:ext cx="2630126" cy="369332"/>
+          </a:xfrm>
+          <a:prstGeom prst="rect">
+            <a:avLst/>
+          </a:prstGeom>
+          <a:noFill/>
+        </p:spPr>
+        <p:txBody>
+          <a:bodyPr wrap="square" rtlCol="0">
+            <a:spAutoFit/>
+          </a:bodyPr>
+          <a:lstStyle/>
+          <a:p>
+            <a:r>
+              <a:rPr lang="en-US" dirty="0"/>
+              <a:t>all high</a:t>
+            </a:r>
+            <a:endParaRPr lang="en-IL" dirty="0"/>
+          </a:p>
+        </p:txBody>
+      </p:sp>
+      <p:sp>
+        <p:nvSpPr>
+          <p:cNvPr id="15" name="Flowchart: Connector 14">
+            <a:extLst>
+              <a:ext uri="{FF2B5EF4-FFF2-40B4-BE49-F238E27FC236}">
+                <a16:creationId xmlns:a16="http://schemas.microsoft.com/office/drawing/2014/main" id="{BCFD6D60-027A-1FE4-805D-AC0BDD584F9A}"/>
+              </a:ext>
+            </a:extLst>
+          </p:cNvPr>
+          <p:cNvSpPr/>
+          <p:nvPr/>
+        </p:nvSpPr>
+        <p:spPr>
+          <a:xfrm>
+            <a:off x="8256994" y="2562542"/>
+            <a:ext cx="360000" cy="360000"/>
+          </a:xfrm>
+          <a:prstGeom prst="flowChartConnector">
+            <a:avLst/>
+          </a:prstGeom>
+          <a:noFill/>
+          <a:ln w="57150">
+            <a:solidFill>
+              <a:srgbClr val="7030A0"/>
+            </a:solidFill>
+          </a:ln>
+        </p:spPr>
+        <p:style>
+          <a:lnRef idx="2">
+            <a:schemeClr val="accent1">
+              <a:shade val="15000"/>
+            </a:schemeClr>
+          </a:lnRef>
+          <a:fillRef idx="1">
+            <a:schemeClr val="accent1"/>
+          </a:fillRef>
+          <a:effectRef idx="0">
+            <a:schemeClr val="accent1"/>
+          </a:effectRef>
+          <a:fontRef idx="minor">
+            <a:schemeClr val="lt1"/>
+          </a:fontRef>
+        </p:style>
+        <p:txBody>
+          <a:bodyPr rtlCol="0" anchor="ctr"/>
+          <a:lstStyle/>
+          <a:p>
+            <a:pPr algn="ctr"/>
+            <a:endParaRPr lang="en-IL"/>
+          </a:p>
+        </p:txBody>
+      </p:sp>
+      <p:sp>
+        <p:nvSpPr>
+          <p:cNvPr id="16" name="TextBox 15">
+            <a:extLst>
+              <a:ext uri="{FF2B5EF4-FFF2-40B4-BE49-F238E27FC236}">
+                <a16:creationId xmlns:a16="http://schemas.microsoft.com/office/drawing/2014/main" id="{99FBBC2B-DFD1-CC39-847A-385C36AC7347}"/>
+              </a:ext>
+            </a:extLst>
+          </p:cNvPr>
+          <p:cNvSpPr txBox="1"/>
+          <p:nvPr/>
+        </p:nvSpPr>
+        <p:spPr>
+          <a:xfrm>
+            <a:off x="8824162" y="2553210"/>
+            <a:ext cx="2837294" cy="369332"/>
+          </a:xfrm>
+          <a:prstGeom prst="rect">
+            <a:avLst/>
+          </a:prstGeom>
+          <a:noFill/>
+        </p:spPr>
+        <p:txBody>
+          <a:bodyPr wrap="square" rtlCol="0">
+            <a:spAutoFit/>
+          </a:bodyPr>
+          <a:lstStyle/>
+          <a:p>
+            <a:r>
+              <a:rPr lang="en-US" dirty="0"/>
+              <a:t>high </a:t>
+            </a:r>
+            <a:r>
+              <a:rPr lang="en-GB" dirty="0"/>
+              <a:t>eigenvector centrality </a:t>
+            </a:r>
+            <a:endParaRPr lang="en-IL" dirty="0"/>
+          </a:p>
+        </p:txBody>
+      </p:sp>
+      <p:sp>
+        <p:nvSpPr>
+          <p:cNvPr id="17" name="Flowchart: Connector 16">
+            <a:extLst>
+              <a:ext uri="{FF2B5EF4-FFF2-40B4-BE49-F238E27FC236}">
+                <a16:creationId xmlns:a16="http://schemas.microsoft.com/office/drawing/2014/main" id="{87C4792C-A2E7-5B20-B256-55095FB999CA}"/>
+              </a:ext>
+            </a:extLst>
+          </p:cNvPr>
+          <p:cNvSpPr/>
+          <p:nvPr/>
+        </p:nvSpPr>
+        <p:spPr>
+          <a:xfrm>
+            <a:off x="4708538" y="2184404"/>
+            <a:ext cx="966331" cy="825496"/>
+          </a:xfrm>
+          <a:prstGeom prst="flowChartConnector">
+            <a:avLst/>
+          </a:prstGeom>
+          <a:noFill/>
+          <a:ln w="57150">
+            <a:solidFill>
+              <a:srgbClr val="7030A0"/>
+            </a:solidFill>
+          </a:ln>
+        </p:spPr>
+        <p:style>
+          <a:lnRef idx="2">
+            <a:schemeClr val="accent1">
+              <a:shade val="15000"/>
+            </a:schemeClr>
+          </a:lnRef>
+          <a:fillRef idx="1">
+            <a:schemeClr val="accent1"/>
+          </a:fillRef>
+          <a:effectRef idx="0">
+            <a:schemeClr val="accent1"/>
+          </a:effectRef>
+          <a:fontRef idx="minor">
+            <a:schemeClr val="lt1"/>
+          </a:fontRef>
+        </p:style>
+        <p:txBody>
+          <a:bodyPr rtlCol="0" anchor="ctr"/>
+          <a:lstStyle/>
+          <a:p>
+            <a:pPr algn="ctr"/>
+            <a:endParaRPr lang="en-IL"/>
+          </a:p>
+        </p:txBody>
+      </p:sp>
+    </p:spTree>
+    <p:extLst>
+      <p:ext uri="{BB962C8B-B14F-4D97-AF65-F5344CB8AC3E}">
+        <p14:creationId xmlns:p14="http://schemas.microsoft.com/office/powerpoint/2010/main" val="1680593382"/>
+      </p:ext>
+    </p:extLst>
+  </p:cSld>
+  <p:clrMapOvr>
+    <a:masterClrMapping/>
+  </p:clrMapOvr>
+</p:sld>
+</file>
+
 <file path=ppt/slides/slide2.xml><?xml version="1.0" encoding="utf-8"?>
 <p:sld xmlns:a="http://schemas.openxmlformats.org/drawingml/2006/main" xmlns:r="http://schemas.openxmlformats.org/officeDocument/2006/relationships" xmlns:p="http://schemas.openxmlformats.org/presentationml/2006/main">
   <p:cSld>
@@ -8465,7 +9408,7 @@
             <p:ph idx="1"/>
             <p:extLst>
               <p:ext uri="{D42A27DB-BD31-4B8C-83A1-F6EECF244321}">
-                <p14:modId xmlns:p14="http://schemas.microsoft.com/office/powerpoint/2010/main" val="3352782491"/>
+                <p14:modId xmlns:p14="http://schemas.microsoft.com/office/powerpoint/2010/main" val="3370926029"/>
               </p:ext>
             </p:extLst>
           </p:nvPr>
@@ -8553,8 +9496,8 @@
         </p:nvSpPr>
         <p:spPr>
           <a:xfrm>
-            <a:off x="4140242" y="5342117"/>
-            <a:ext cx="2117124" cy="642551"/>
+            <a:off x="3932608" y="5410867"/>
+            <a:ext cx="2149642" cy="642551"/>
           </a:xfrm>
           <a:prstGeom prst="roundRect">
             <a:avLst/>
@@ -8606,8 +9549,8 @@
         </p:nvCxnSpPr>
         <p:spPr>
           <a:xfrm flipV="1">
-            <a:off x="6257366" y="4446494"/>
-            <a:ext cx="869575" cy="1216899"/>
+            <a:off x="6082250" y="4455122"/>
+            <a:ext cx="834189" cy="1277021"/>
           </a:xfrm>
           <a:prstGeom prst="straightConnector1">
             <a:avLst/>
@@ -9387,14 +10330,13 @@
           <a:bodyPr/>
           <a:lstStyle/>
           <a:p>
-            <a:pPr fontAlgn="base"/>
             <a:r>
               <a:rPr lang="en-GB" b="1" dirty="0"/>
               <a:t>Information Operation (IO):</a:t>
             </a:r>
             <a:r>
               <a:rPr lang="en-GB" dirty="0"/>
-              <a:t> A collection of publications produced by a set of actors performing similar or complementary actions in pursuit of a shared intent  while misleading others.</a:t>
+              <a:t> A collection of publications by coordinated actors pursuing a shared intent while misleading others.</a:t>
             </a:r>
           </a:p>
           <a:p>
@@ -9773,6 +10715,188 @@
   <p:cSld>
     <p:spTree>
       <p:nvGrpSpPr>
+        <p:cNvPr id="1" name="">
+          <a:extLst>
+            <a:ext uri="{FF2B5EF4-FFF2-40B4-BE49-F238E27FC236}">
+              <a16:creationId xmlns:a16="http://schemas.microsoft.com/office/drawing/2014/main" id="{858E27CD-C8FF-B185-45D8-666A78A68D92}"/>
+            </a:ext>
+          </a:extLst>
+        </p:cNvPr>
+        <p:cNvGrpSpPr/>
+        <p:nvPr/>
+      </p:nvGrpSpPr>
+      <p:grpSpPr>
+        <a:xfrm>
+          <a:off x="0" y="0"/>
+          <a:ext cx="0" cy="0"/>
+          <a:chOff x="0" y="0"/>
+          <a:chExt cx="0" cy="0"/>
+        </a:xfrm>
+      </p:grpSpPr>
+      <p:sp>
+        <p:nvSpPr>
+          <p:cNvPr id="2" name="Title 1">
+            <a:extLst>
+              <a:ext uri="{FF2B5EF4-FFF2-40B4-BE49-F238E27FC236}">
+                <a16:creationId xmlns:a16="http://schemas.microsoft.com/office/drawing/2014/main" id="{A5798079-07AB-1011-721B-DDEB468739BA}"/>
+              </a:ext>
+            </a:extLst>
+          </p:cNvPr>
+          <p:cNvSpPr>
+            <a:spLocks noGrp="1"/>
+          </p:cNvSpPr>
+          <p:nvPr>
+            <p:ph type="title"/>
+          </p:nvPr>
+        </p:nvSpPr>
+        <p:spPr>
+          <a:xfrm>
+            <a:off x="3072268" y="401637"/>
+            <a:ext cx="8949044" cy="1325563"/>
+          </a:xfrm>
+        </p:spPr>
+        <p:txBody>
+          <a:bodyPr>
+            <a:normAutofit/>
+          </a:bodyPr>
+          <a:lstStyle/>
+          <a:p>
+            <a:r>
+              <a:rPr lang="en-GB" dirty="0"/>
+              <a:t>Backbone Graph</a:t>
+            </a:r>
+            <a:endParaRPr lang="en-IL" dirty="0"/>
+          </a:p>
+        </p:txBody>
+      </p:sp>
+      <p:sp>
+        <p:nvSpPr>
+          <p:cNvPr id="3" name="Content Placeholder 2">
+            <a:extLst>
+              <a:ext uri="{FF2B5EF4-FFF2-40B4-BE49-F238E27FC236}">
+                <a16:creationId xmlns:a16="http://schemas.microsoft.com/office/drawing/2014/main" id="{5FBFF6C3-80E1-C75C-69F0-3A7FFA1D100D}"/>
+              </a:ext>
+            </a:extLst>
+          </p:cNvPr>
+          <p:cNvSpPr>
+            <a:spLocks noGrp="1"/>
+          </p:cNvSpPr>
+          <p:nvPr>
+            <p:ph idx="1"/>
+          </p:nvPr>
+        </p:nvSpPr>
+        <p:spPr>
+          <a:xfrm>
+            <a:off x="1243087" y="1825624"/>
+            <a:ext cx="10582656" cy="4441825"/>
+          </a:xfrm>
+        </p:spPr>
+        <p:txBody>
+          <a:bodyPr>
+            <a:normAutofit/>
+          </a:bodyPr>
+          <a:lstStyle/>
+          <a:p>
+            <a:r>
+              <a:rPr lang="en-GB" sz="2800" b="1" dirty="0"/>
+              <a:t>Nodes:</a:t>
+            </a:r>
+            <a:r>
+              <a:rPr lang="en-GB" sz="2800" dirty="0"/>
+              <a:t> Key authors.</a:t>
+            </a:r>
+          </a:p>
+          <a:p>
+            <a:r>
+              <a:rPr lang="en-GB" sz="2800" b="1" dirty="0"/>
+              <a:t>Edges: </a:t>
+            </a:r>
+            <a:r>
+              <a:rPr lang="en-GB" sz="2800" dirty="0"/>
+              <a:t>Represent behavioural similarity, based on co-actions (e.g. same hashtag usage, repos)</a:t>
+            </a:r>
+          </a:p>
+          <a:p>
+            <a:r>
+              <a:rPr lang="en-GB" sz="2800" b="1" dirty="0"/>
+              <a:t>Edges’ Weights:</a:t>
+            </a:r>
+            <a:r>
+              <a:rPr lang="en-GB" sz="2800" dirty="0"/>
+              <a:t> The number of the occurrences of co-actions between the authors.</a:t>
+            </a:r>
+          </a:p>
+          <a:p>
+            <a:r>
+              <a:rPr lang="en-GB" sz="2800" b="1" dirty="0"/>
+              <a:t>Purpose</a:t>
+            </a:r>
+            <a:r>
+              <a:rPr lang="en-GB" sz="2800" dirty="0"/>
+              <a:t>: Represent the discussion structure and expose signals of coordinated behaviour for IO detection.</a:t>
+            </a:r>
+          </a:p>
+          <a:p>
+            <a:endParaRPr lang="en-GB" dirty="0"/>
+          </a:p>
+          <a:p>
+            <a:endParaRPr lang="en-GB" dirty="0"/>
+          </a:p>
+          <a:p>
+            <a:pPr marL="457200" lvl="1" indent="0">
+              <a:buNone/>
+            </a:pPr>
+            <a:endParaRPr lang="en-GB" sz="3300" dirty="0"/>
+          </a:p>
+        </p:txBody>
+      </p:sp>
+      <p:sp>
+        <p:nvSpPr>
+          <p:cNvPr id="4" name="Slide Number Placeholder 3">
+            <a:extLst>
+              <a:ext uri="{FF2B5EF4-FFF2-40B4-BE49-F238E27FC236}">
+                <a16:creationId xmlns:a16="http://schemas.microsoft.com/office/drawing/2014/main" id="{705E3158-F388-D9C9-D303-42FD2F68D2FC}"/>
+              </a:ext>
+            </a:extLst>
+          </p:cNvPr>
+          <p:cNvSpPr>
+            <a:spLocks noGrp="1"/>
+          </p:cNvSpPr>
+          <p:nvPr>
+            <p:ph type="sldNum" sz="quarter" idx="12"/>
+          </p:nvPr>
+        </p:nvSpPr>
+        <p:spPr/>
+        <p:txBody>
+          <a:bodyPr/>
+          <a:lstStyle/>
+          <a:p>
+            <a:fld id="{E6AB8EDD-9EF2-4633-A1C2-4D908C1019B4}" type="slidenum">
+              <a:rPr lang="he-IL" smtClean="0"/>
+              <a:t>8</a:t>
+            </a:fld>
+            <a:endParaRPr lang="he-IL"/>
+          </a:p>
+        </p:txBody>
+      </p:sp>
+    </p:spTree>
+    <p:extLst>
+      <p:ext uri="{BB962C8B-B14F-4D97-AF65-F5344CB8AC3E}">
+        <p14:creationId xmlns:p14="http://schemas.microsoft.com/office/powerpoint/2010/main" val="3011122290"/>
+      </p:ext>
+    </p:extLst>
+  </p:cSld>
+  <p:clrMapOvr>
+    <a:masterClrMapping/>
+  </p:clrMapOvr>
+</p:sld>
+</file>
+
+<file path=ppt/slides/slide9.xml><?xml version="1.0" encoding="utf-8"?>
+<p:sld xmlns:a="http://schemas.openxmlformats.org/drawingml/2006/main" xmlns:r="http://schemas.openxmlformats.org/officeDocument/2006/relationships" xmlns:p="http://schemas.openxmlformats.org/presentationml/2006/main">
+  <p:cSld>
+    <p:spTree>
+      <p:nvGrpSpPr>
         <p:cNvPr id="1" name=""/>
         <p:cNvGrpSpPr/>
         <p:nvPr/>
@@ -9983,7 +11107,7 @@
           <a:p>
             <a:fld id="{E6AB8EDD-9EF2-4633-A1C2-4D908C1019B4}" type="slidenum">
               <a:rPr lang="he-IL" smtClean="0"/>
-              <a:t>8</a:t>
+              <a:t>9</a:t>
             </a:fld>
             <a:endParaRPr lang="he-IL"/>
           </a:p>

</xml_diff>